<commit_message>
updates to readme and script relationships powerpoint
</commit_message>
<xml_diff>
--- a/script_relationships.pptx
+++ b/script_relationships.pptx
@@ -261,7 +261,7 @@
           <a:p>
             <a:fld id="{0E339DDD-9EE9-44F5-8997-0932F1FFC27B}" type="datetimeFigureOut">
               <a:rPr lang="en-ZA" smtClean="0"/>
-              <a:t>2025/02/21</a:t>
+              <a:t>2026/02/04</a:t>
             </a:fld>
             <a:endParaRPr lang="en-ZA"/>
           </a:p>
@@ -461,7 +461,7 @@
           <a:p>
             <a:fld id="{0E339DDD-9EE9-44F5-8997-0932F1FFC27B}" type="datetimeFigureOut">
               <a:rPr lang="en-ZA" smtClean="0"/>
-              <a:t>2025/02/21</a:t>
+              <a:t>2026/02/04</a:t>
             </a:fld>
             <a:endParaRPr lang="en-ZA"/>
           </a:p>
@@ -671,7 +671,7 @@
           <a:p>
             <a:fld id="{0E339DDD-9EE9-44F5-8997-0932F1FFC27B}" type="datetimeFigureOut">
               <a:rPr lang="en-ZA" smtClean="0"/>
-              <a:t>2025/02/21</a:t>
+              <a:t>2026/02/04</a:t>
             </a:fld>
             <a:endParaRPr lang="en-ZA"/>
           </a:p>
@@ -871,7 +871,7 @@
           <a:p>
             <a:fld id="{0E339DDD-9EE9-44F5-8997-0932F1FFC27B}" type="datetimeFigureOut">
               <a:rPr lang="en-ZA" smtClean="0"/>
-              <a:t>2025/02/21</a:t>
+              <a:t>2026/02/04</a:t>
             </a:fld>
             <a:endParaRPr lang="en-ZA"/>
           </a:p>
@@ -1147,7 +1147,7 @@
           <a:p>
             <a:fld id="{0E339DDD-9EE9-44F5-8997-0932F1FFC27B}" type="datetimeFigureOut">
               <a:rPr lang="en-ZA" smtClean="0"/>
-              <a:t>2025/02/21</a:t>
+              <a:t>2026/02/04</a:t>
             </a:fld>
             <a:endParaRPr lang="en-ZA"/>
           </a:p>
@@ -1415,7 +1415,7 @@
           <a:p>
             <a:fld id="{0E339DDD-9EE9-44F5-8997-0932F1FFC27B}" type="datetimeFigureOut">
               <a:rPr lang="en-ZA" smtClean="0"/>
-              <a:t>2025/02/21</a:t>
+              <a:t>2026/02/04</a:t>
             </a:fld>
             <a:endParaRPr lang="en-ZA"/>
           </a:p>
@@ -1830,7 +1830,7 @@
           <a:p>
             <a:fld id="{0E339DDD-9EE9-44F5-8997-0932F1FFC27B}" type="datetimeFigureOut">
               <a:rPr lang="en-ZA" smtClean="0"/>
-              <a:t>2025/02/21</a:t>
+              <a:t>2026/02/04</a:t>
             </a:fld>
             <a:endParaRPr lang="en-ZA"/>
           </a:p>
@@ -1972,7 +1972,7 @@
           <a:p>
             <a:fld id="{0E339DDD-9EE9-44F5-8997-0932F1FFC27B}" type="datetimeFigureOut">
               <a:rPr lang="en-ZA" smtClean="0"/>
-              <a:t>2025/02/21</a:t>
+              <a:t>2026/02/04</a:t>
             </a:fld>
             <a:endParaRPr lang="en-ZA"/>
           </a:p>
@@ -2085,7 +2085,7 @@
           <a:p>
             <a:fld id="{0E339DDD-9EE9-44F5-8997-0932F1FFC27B}" type="datetimeFigureOut">
               <a:rPr lang="en-ZA" smtClean="0"/>
-              <a:t>2025/02/21</a:t>
+              <a:t>2026/02/04</a:t>
             </a:fld>
             <a:endParaRPr lang="en-ZA"/>
           </a:p>
@@ -2398,7 +2398,7 @@
           <a:p>
             <a:fld id="{0E339DDD-9EE9-44F5-8997-0932F1FFC27B}" type="datetimeFigureOut">
               <a:rPr lang="en-ZA" smtClean="0"/>
-              <a:t>2025/02/21</a:t>
+              <a:t>2026/02/04</a:t>
             </a:fld>
             <a:endParaRPr lang="en-ZA"/>
           </a:p>
@@ -2687,7 +2687,7 @@
           <a:p>
             <a:fld id="{0E339DDD-9EE9-44F5-8997-0932F1FFC27B}" type="datetimeFigureOut">
               <a:rPr lang="en-ZA" smtClean="0"/>
-              <a:t>2025/02/21</a:t>
+              <a:t>2026/02/04</a:t>
             </a:fld>
             <a:endParaRPr lang="en-ZA"/>
           </a:p>
@@ -2930,7 +2930,7 @@
           <a:p>
             <a:fld id="{0E339DDD-9EE9-44F5-8997-0932F1FFC27B}" type="datetimeFigureOut">
               <a:rPr lang="en-ZA" smtClean="0"/>
-              <a:t>2025/02/21</a:t>
+              <a:t>2026/02/04</a:t>
             </a:fld>
             <a:endParaRPr lang="en-ZA"/>
           </a:p>
@@ -4650,12 +4650,20 @@
           <a:p>
             <a:pPr algn="ctr"/>
             <a:r>
-              <a:rPr lang="en-US" sz="600" dirty="0" err="1">
+              <a:rPr lang="en-US" sz="600" dirty="0">
                 <a:solidFill>
                   <a:srgbClr val="7030A0"/>
                 </a:solidFill>
               </a:rPr>
-              <a:t>Zeta_msgdm_change_seed</a:t>
+              <a:t>7_Zeta_msgdm_change</a:t>
+            </a:r>
+            <a:r>
+              <a:rPr lang="en-US" sz="600">
+                <a:solidFill>
+                  <a:srgbClr val="7030A0"/>
+                </a:solidFill>
+              </a:rPr>
+              <a:t>_seed_analyses</a:t>
             </a:r>
             <a:endParaRPr lang="en-ZA" sz="600" dirty="0">
               <a:solidFill>

</xml_diff>

<commit_message>
Update of readme and annotation for process_msgdm_results.Rmd (generates Fig S4, variance partitioning, variance explained)
</commit_message>
<xml_diff>
--- a/script_relationships.pptx
+++ b/script_relationships.pptx
@@ -261,7 +261,7 @@
           <a:p>
             <a:fld id="{0E339DDD-9EE9-44F5-8997-0932F1FFC27B}" type="datetimeFigureOut">
               <a:rPr lang="en-ZA" smtClean="0"/>
-              <a:t>2026/02/05</a:t>
+              <a:t>2026/05/15</a:t>
             </a:fld>
             <a:endParaRPr lang="en-ZA"/>
           </a:p>
@@ -461,7 +461,7 @@
           <a:p>
             <a:fld id="{0E339DDD-9EE9-44F5-8997-0932F1FFC27B}" type="datetimeFigureOut">
               <a:rPr lang="en-ZA" smtClean="0"/>
-              <a:t>2026/02/05</a:t>
+              <a:t>2026/05/15</a:t>
             </a:fld>
             <a:endParaRPr lang="en-ZA"/>
           </a:p>
@@ -671,7 +671,7 @@
           <a:p>
             <a:fld id="{0E339DDD-9EE9-44F5-8997-0932F1FFC27B}" type="datetimeFigureOut">
               <a:rPr lang="en-ZA" smtClean="0"/>
-              <a:t>2026/02/05</a:t>
+              <a:t>2026/05/15</a:t>
             </a:fld>
             <a:endParaRPr lang="en-ZA"/>
           </a:p>
@@ -871,7 +871,7 @@
           <a:p>
             <a:fld id="{0E339DDD-9EE9-44F5-8997-0932F1FFC27B}" type="datetimeFigureOut">
               <a:rPr lang="en-ZA" smtClean="0"/>
-              <a:t>2026/02/05</a:t>
+              <a:t>2026/05/15</a:t>
             </a:fld>
             <a:endParaRPr lang="en-ZA"/>
           </a:p>
@@ -1147,7 +1147,7 @@
           <a:p>
             <a:fld id="{0E339DDD-9EE9-44F5-8997-0932F1FFC27B}" type="datetimeFigureOut">
               <a:rPr lang="en-ZA" smtClean="0"/>
-              <a:t>2026/02/05</a:t>
+              <a:t>2026/05/15</a:t>
             </a:fld>
             <a:endParaRPr lang="en-ZA"/>
           </a:p>
@@ -1415,7 +1415,7 @@
           <a:p>
             <a:fld id="{0E339DDD-9EE9-44F5-8997-0932F1FFC27B}" type="datetimeFigureOut">
               <a:rPr lang="en-ZA" smtClean="0"/>
-              <a:t>2026/02/05</a:t>
+              <a:t>2026/05/15</a:t>
             </a:fld>
             <a:endParaRPr lang="en-ZA"/>
           </a:p>
@@ -1830,7 +1830,7 @@
           <a:p>
             <a:fld id="{0E339DDD-9EE9-44F5-8997-0932F1FFC27B}" type="datetimeFigureOut">
               <a:rPr lang="en-ZA" smtClean="0"/>
-              <a:t>2026/02/05</a:t>
+              <a:t>2026/05/15</a:t>
             </a:fld>
             <a:endParaRPr lang="en-ZA"/>
           </a:p>
@@ -1972,7 +1972,7 @@
           <a:p>
             <a:fld id="{0E339DDD-9EE9-44F5-8997-0932F1FFC27B}" type="datetimeFigureOut">
               <a:rPr lang="en-ZA" smtClean="0"/>
-              <a:t>2026/02/05</a:t>
+              <a:t>2026/05/15</a:t>
             </a:fld>
             <a:endParaRPr lang="en-ZA"/>
           </a:p>
@@ -2085,7 +2085,7 @@
           <a:p>
             <a:fld id="{0E339DDD-9EE9-44F5-8997-0932F1FFC27B}" type="datetimeFigureOut">
               <a:rPr lang="en-ZA" smtClean="0"/>
-              <a:t>2026/02/05</a:t>
+              <a:t>2026/05/15</a:t>
             </a:fld>
             <a:endParaRPr lang="en-ZA"/>
           </a:p>
@@ -2398,7 +2398,7 @@
           <a:p>
             <a:fld id="{0E339DDD-9EE9-44F5-8997-0932F1FFC27B}" type="datetimeFigureOut">
               <a:rPr lang="en-ZA" smtClean="0"/>
-              <a:t>2026/02/05</a:t>
+              <a:t>2026/05/15</a:t>
             </a:fld>
             <a:endParaRPr lang="en-ZA"/>
           </a:p>
@@ -2687,7 +2687,7 @@
           <a:p>
             <a:fld id="{0E339DDD-9EE9-44F5-8997-0932F1FFC27B}" type="datetimeFigureOut">
               <a:rPr lang="en-ZA" smtClean="0"/>
-              <a:t>2026/02/05</a:t>
+              <a:t>2026/05/15</a:t>
             </a:fld>
             <a:endParaRPr lang="en-ZA"/>
           </a:p>
@@ -2930,7 +2930,7 @@
           <a:p>
             <a:fld id="{0E339DDD-9EE9-44F5-8997-0932F1FFC27B}" type="datetimeFigureOut">
               <a:rPr lang="en-ZA" smtClean="0"/>
-              <a:t>2026/02/05</a:t>
+              <a:t>2026/05/15</a:t>
             </a:fld>
             <a:endParaRPr lang="en-ZA"/>
           </a:p>
@@ -4587,12 +4587,12 @@
           <a:p>
             <a:pPr algn="ctr"/>
             <a:r>
-              <a:rPr lang="en-US" sz="600" dirty="0" err="1">
+              <a:rPr lang="en-US" sz="600" dirty="0">
                 <a:solidFill>
                   <a:srgbClr val="7030A0"/>
                 </a:solidFill>
               </a:rPr>
-              <a:t>MSGDM_multipanel_plot.Rmd</a:t>
+              <a:t>8_MSGDM_multipanel_plot.Rmd</a:t>
             </a:r>
             <a:endParaRPr lang="en-ZA" sz="600" dirty="0">
               <a:solidFill>
@@ -7560,7 +7560,7 @@
         </p:nvSpPr>
         <p:spPr>
           <a:xfrm>
-            <a:off x="9510190" y="6201232"/>
+            <a:off x="10008720" y="6310177"/>
             <a:ext cx="928789" cy="385278"/>
           </a:xfrm>
           <a:prstGeom prst="flowChartDocument">
@@ -7607,13 +7607,15 @@
           </p:cNvPr>
           <p:cNvCxnSpPr>
             <a:cxnSpLocks/>
+            <a:stCxn id="224" idx="3"/>
+            <a:endCxn id="14" idx="1"/>
           </p:cNvCxnSpPr>
           <p:nvPr/>
         </p:nvCxnSpPr>
         <p:spPr>
           <a:xfrm>
-            <a:off x="8551550" y="5833621"/>
-            <a:ext cx="985091" cy="948703"/>
+            <a:off x="8979911" y="6448420"/>
+            <a:ext cx="1028809" cy="54396"/>
           </a:xfrm>
           <a:prstGeom prst="straightConnector1">
             <a:avLst/>
@@ -7651,7 +7653,7 @@
         </p:nvSpPr>
         <p:spPr>
           <a:xfrm>
-            <a:off x="7568378" y="6098568"/>
+            <a:off x="7781547" y="6109388"/>
             <a:ext cx="1198364" cy="678063"/>
           </a:xfrm>
           <a:prstGeom prst="flowChartDecision">
@@ -7700,6 +7702,49 @@
           </a:p>
         </p:txBody>
       </p:sp>
+      <p:cxnSp>
+        <p:nvCxnSpPr>
+          <p:cNvPr id="226" name="Straight Arrow Connector 225">
+            <a:extLst>
+              <a:ext uri="{FF2B5EF4-FFF2-40B4-BE49-F238E27FC236}">
+                <a16:creationId xmlns:a16="http://schemas.microsoft.com/office/drawing/2014/main" id="{C5ADAA32-699E-12E2-778B-64CE08F6D428}"/>
+              </a:ext>
+            </a:extLst>
+          </p:cNvPr>
+          <p:cNvCxnSpPr>
+            <a:cxnSpLocks/>
+            <a:stCxn id="39" idx="3"/>
+            <a:endCxn id="224" idx="1"/>
+          </p:cNvCxnSpPr>
+          <p:nvPr/>
+        </p:nvCxnSpPr>
+        <p:spPr>
+          <a:xfrm>
+            <a:off x="7045586" y="5373454"/>
+            <a:ext cx="735961" cy="1074966"/>
+          </a:xfrm>
+          <a:prstGeom prst="straightConnector1">
+            <a:avLst/>
+          </a:prstGeom>
+          <a:ln>
+            <a:tailEnd type="triangle"/>
+          </a:ln>
+        </p:spPr>
+        <p:style>
+          <a:lnRef idx="2">
+            <a:schemeClr val="accent1"/>
+          </a:lnRef>
+          <a:fillRef idx="0">
+            <a:schemeClr val="accent1"/>
+          </a:fillRef>
+          <a:effectRef idx="1">
+            <a:schemeClr val="accent1"/>
+          </a:effectRef>
+          <a:fontRef idx="minor">
+            <a:schemeClr val="tx1"/>
+          </a:fontRef>
+        </p:style>
+      </p:cxnSp>
     </p:spTree>
     <p:extLst>
       <p:ext uri="{BB962C8B-B14F-4D97-AF65-F5344CB8AC3E}">

</xml_diff>

<commit_message>
ppt minor arrow change
</commit_message>
<xml_diff>
--- a/script_relationships.pptx
+++ b/script_relationships.pptx
@@ -261,7 +261,7 @@
           <a:p>
             <a:fld id="{0E339DDD-9EE9-44F5-8997-0932F1FFC27B}" type="datetimeFigureOut">
               <a:rPr lang="en-ZA" smtClean="0"/>
-              <a:t>2026/05/15</a:t>
+              <a:t>2026/06/02</a:t>
             </a:fld>
             <a:endParaRPr lang="en-ZA"/>
           </a:p>
@@ -461,7 +461,7 @@
           <a:p>
             <a:fld id="{0E339DDD-9EE9-44F5-8997-0932F1FFC27B}" type="datetimeFigureOut">
               <a:rPr lang="en-ZA" smtClean="0"/>
-              <a:t>2026/05/15</a:t>
+              <a:t>2026/06/02</a:t>
             </a:fld>
             <a:endParaRPr lang="en-ZA"/>
           </a:p>
@@ -671,7 +671,7 @@
           <a:p>
             <a:fld id="{0E339DDD-9EE9-44F5-8997-0932F1FFC27B}" type="datetimeFigureOut">
               <a:rPr lang="en-ZA" smtClean="0"/>
-              <a:t>2026/05/15</a:t>
+              <a:t>2026/06/02</a:t>
             </a:fld>
             <a:endParaRPr lang="en-ZA"/>
           </a:p>
@@ -871,7 +871,7 @@
           <a:p>
             <a:fld id="{0E339DDD-9EE9-44F5-8997-0932F1FFC27B}" type="datetimeFigureOut">
               <a:rPr lang="en-ZA" smtClean="0"/>
-              <a:t>2026/05/15</a:t>
+              <a:t>2026/06/02</a:t>
             </a:fld>
             <a:endParaRPr lang="en-ZA"/>
           </a:p>
@@ -1147,7 +1147,7 @@
           <a:p>
             <a:fld id="{0E339DDD-9EE9-44F5-8997-0932F1FFC27B}" type="datetimeFigureOut">
               <a:rPr lang="en-ZA" smtClean="0"/>
-              <a:t>2026/05/15</a:t>
+              <a:t>2026/06/02</a:t>
             </a:fld>
             <a:endParaRPr lang="en-ZA"/>
           </a:p>
@@ -1415,7 +1415,7 @@
           <a:p>
             <a:fld id="{0E339DDD-9EE9-44F5-8997-0932F1FFC27B}" type="datetimeFigureOut">
               <a:rPr lang="en-ZA" smtClean="0"/>
-              <a:t>2026/05/15</a:t>
+              <a:t>2026/06/02</a:t>
             </a:fld>
             <a:endParaRPr lang="en-ZA"/>
           </a:p>
@@ -1830,7 +1830,7 @@
           <a:p>
             <a:fld id="{0E339DDD-9EE9-44F5-8997-0932F1FFC27B}" type="datetimeFigureOut">
               <a:rPr lang="en-ZA" smtClean="0"/>
-              <a:t>2026/05/15</a:t>
+              <a:t>2026/06/02</a:t>
             </a:fld>
             <a:endParaRPr lang="en-ZA"/>
           </a:p>
@@ -1972,7 +1972,7 @@
           <a:p>
             <a:fld id="{0E339DDD-9EE9-44F5-8997-0932F1FFC27B}" type="datetimeFigureOut">
               <a:rPr lang="en-ZA" smtClean="0"/>
-              <a:t>2026/05/15</a:t>
+              <a:t>2026/06/02</a:t>
             </a:fld>
             <a:endParaRPr lang="en-ZA"/>
           </a:p>
@@ -2085,7 +2085,7 @@
           <a:p>
             <a:fld id="{0E339DDD-9EE9-44F5-8997-0932F1FFC27B}" type="datetimeFigureOut">
               <a:rPr lang="en-ZA" smtClean="0"/>
-              <a:t>2026/05/15</a:t>
+              <a:t>2026/06/02</a:t>
             </a:fld>
             <a:endParaRPr lang="en-ZA"/>
           </a:p>
@@ -2398,7 +2398,7 @@
           <a:p>
             <a:fld id="{0E339DDD-9EE9-44F5-8997-0932F1FFC27B}" type="datetimeFigureOut">
               <a:rPr lang="en-ZA" smtClean="0"/>
-              <a:t>2026/05/15</a:t>
+              <a:t>2026/06/02</a:t>
             </a:fld>
             <a:endParaRPr lang="en-ZA"/>
           </a:p>
@@ -2687,7 +2687,7 @@
           <a:p>
             <a:fld id="{0E339DDD-9EE9-44F5-8997-0932F1FFC27B}" type="datetimeFigureOut">
               <a:rPr lang="en-ZA" smtClean="0"/>
-              <a:t>2026/05/15</a:t>
+              <a:t>2026/06/02</a:t>
             </a:fld>
             <a:endParaRPr lang="en-ZA"/>
           </a:p>
@@ -2930,7 +2930,7 @@
           <a:p>
             <a:fld id="{0E339DDD-9EE9-44F5-8997-0932F1FFC27B}" type="datetimeFigureOut">
               <a:rPr lang="en-ZA" smtClean="0"/>
-              <a:t>2026/05/15</a:t>
+              <a:t>2026/06/02</a:t>
             </a:fld>
             <a:endParaRPr lang="en-ZA"/>
           </a:p>
@@ -4524,12 +4524,12 @@
           <a:p>
             <a:pPr algn="ctr"/>
             <a:r>
-              <a:rPr lang="en-US" sz="600" dirty="0" err="1">
+              <a:rPr lang="en-US" sz="600" dirty="0">
                 <a:solidFill>
                   <a:srgbClr val="7030A0"/>
                 </a:solidFill>
               </a:rPr>
-              <a:t>GAM_compare_family_analyses.Rmd</a:t>
+              <a:t>10_GAM_compare_family_analyses.Rmd</a:t>
             </a:r>
             <a:endParaRPr lang="en-ZA" sz="600" dirty="0">
               <a:solidFill>
@@ -5601,15 +5601,13 @@
           </p:cNvPr>
           <p:cNvCxnSpPr>
             <a:cxnSpLocks/>
-            <a:stCxn id="183" idx="2"/>
-            <a:endCxn id="2" idx="1"/>
           </p:cNvCxnSpPr>
           <p:nvPr/>
         </p:nvCxnSpPr>
         <p:spPr>
-          <a:xfrm flipH="1">
-            <a:off x="4566576" y="3591394"/>
-            <a:ext cx="107158" cy="488486"/>
+          <a:xfrm>
+            <a:off x="4451702" y="3634824"/>
+            <a:ext cx="0" cy="340435"/>
           </a:xfrm>
           <a:prstGeom prst="straightConnector1">
             <a:avLst/>
@@ -6911,12 +6909,12 @@
             <a:p>
               <a:pPr algn="ctr"/>
               <a:r>
-                <a:rPr lang="en-US" sz="600" dirty="0" err="1">
+                <a:rPr lang="en-US" sz="600" dirty="0">
                   <a:solidFill>
                     <a:srgbClr val="7030A0"/>
                   </a:solidFill>
                 </a:rPr>
-                <a:t>GAM_compare_spline_analyses.Rmd</a:t>
+                <a:t>11_GAM_compare_spline_analyses.Rmd</a:t>
               </a:r>
               <a:endParaRPr lang="en-ZA" sz="600" dirty="0">
                 <a:solidFill>

</xml_diff>

<commit_message>
Updated annotation and documentation for script to compare gamm correlation structures, this become script 12
</commit_message>
<xml_diff>
--- a/script_relationships.pptx
+++ b/script_relationships.pptx
@@ -261,7 +261,7 @@
           <a:p>
             <a:fld id="{0E339DDD-9EE9-44F5-8997-0932F1FFC27B}" type="datetimeFigureOut">
               <a:rPr lang="en-ZA" smtClean="0"/>
-              <a:t>2026/06/02</a:t>
+              <a:t>2026/06/04</a:t>
             </a:fld>
             <a:endParaRPr lang="en-ZA"/>
           </a:p>
@@ -461,7 +461,7 @@
           <a:p>
             <a:fld id="{0E339DDD-9EE9-44F5-8997-0932F1FFC27B}" type="datetimeFigureOut">
               <a:rPr lang="en-ZA" smtClean="0"/>
-              <a:t>2026/06/02</a:t>
+              <a:t>2026/06/04</a:t>
             </a:fld>
             <a:endParaRPr lang="en-ZA"/>
           </a:p>
@@ -671,7 +671,7 @@
           <a:p>
             <a:fld id="{0E339DDD-9EE9-44F5-8997-0932F1FFC27B}" type="datetimeFigureOut">
               <a:rPr lang="en-ZA" smtClean="0"/>
-              <a:t>2026/06/02</a:t>
+              <a:t>2026/06/04</a:t>
             </a:fld>
             <a:endParaRPr lang="en-ZA"/>
           </a:p>
@@ -871,7 +871,7 @@
           <a:p>
             <a:fld id="{0E339DDD-9EE9-44F5-8997-0932F1FFC27B}" type="datetimeFigureOut">
               <a:rPr lang="en-ZA" smtClean="0"/>
-              <a:t>2026/06/02</a:t>
+              <a:t>2026/06/04</a:t>
             </a:fld>
             <a:endParaRPr lang="en-ZA"/>
           </a:p>
@@ -1147,7 +1147,7 @@
           <a:p>
             <a:fld id="{0E339DDD-9EE9-44F5-8997-0932F1FFC27B}" type="datetimeFigureOut">
               <a:rPr lang="en-ZA" smtClean="0"/>
-              <a:t>2026/06/02</a:t>
+              <a:t>2026/06/04</a:t>
             </a:fld>
             <a:endParaRPr lang="en-ZA"/>
           </a:p>
@@ -1415,7 +1415,7 @@
           <a:p>
             <a:fld id="{0E339DDD-9EE9-44F5-8997-0932F1FFC27B}" type="datetimeFigureOut">
               <a:rPr lang="en-ZA" smtClean="0"/>
-              <a:t>2026/06/02</a:t>
+              <a:t>2026/06/04</a:t>
             </a:fld>
             <a:endParaRPr lang="en-ZA"/>
           </a:p>
@@ -1830,7 +1830,7 @@
           <a:p>
             <a:fld id="{0E339DDD-9EE9-44F5-8997-0932F1FFC27B}" type="datetimeFigureOut">
               <a:rPr lang="en-ZA" smtClean="0"/>
-              <a:t>2026/06/02</a:t>
+              <a:t>2026/06/04</a:t>
             </a:fld>
             <a:endParaRPr lang="en-ZA"/>
           </a:p>
@@ -1972,7 +1972,7 @@
           <a:p>
             <a:fld id="{0E339DDD-9EE9-44F5-8997-0932F1FFC27B}" type="datetimeFigureOut">
               <a:rPr lang="en-ZA" smtClean="0"/>
-              <a:t>2026/06/02</a:t>
+              <a:t>2026/06/04</a:t>
             </a:fld>
             <a:endParaRPr lang="en-ZA"/>
           </a:p>
@@ -2085,7 +2085,7 @@
           <a:p>
             <a:fld id="{0E339DDD-9EE9-44F5-8997-0932F1FFC27B}" type="datetimeFigureOut">
               <a:rPr lang="en-ZA" smtClean="0"/>
-              <a:t>2026/06/02</a:t>
+              <a:t>2026/06/04</a:t>
             </a:fld>
             <a:endParaRPr lang="en-ZA"/>
           </a:p>
@@ -2398,7 +2398,7 @@
           <a:p>
             <a:fld id="{0E339DDD-9EE9-44F5-8997-0932F1FFC27B}" type="datetimeFigureOut">
               <a:rPr lang="en-ZA" smtClean="0"/>
-              <a:t>2026/06/02</a:t>
+              <a:t>2026/06/04</a:t>
             </a:fld>
             <a:endParaRPr lang="en-ZA"/>
           </a:p>
@@ -2687,7 +2687,7 @@
           <a:p>
             <a:fld id="{0E339DDD-9EE9-44F5-8997-0932F1FFC27B}" type="datetimeFigureOut">
               <a:rPr lang="en-ZA" smtClean="0"/>
-              <a:t>2026/06/02</a:t>
+              <a:t>2026/06/04</a:t>
             </a:fld>
             <a:endParaRPr lang="en-ZA"/>
           </a:p>
@@ -2930,7 +2930,7 @@
           <a:p>
             <a:fld id="{0E339DDD-9EE9-44F5-8997-0932F1FFC27B}" type="datetimeFigureOut">
               <a:rPr lang="en-ZA" smtClean="0"/>
-              <a:t>2026/06/02</a:t>
+              <a:t>2026/06/04</a:t>
             </a:fld>
             <a:endParaRPr lang="en-ZA"/>
           </a:p>
@@ -3358,14 +3358,15 @@
           </p:cNvPr>
           <p:cNvCxnSpPr>
             <a:cxnSpLocks/>
+            <a:stCxn id="62" idx="0"/>
             <a:endCxn id="163" idx="2"/>
           </p:cNvCxnSpPr>
           <p:nvPr/>
         </p:nvCxnSpPr>
         <p:spPr>
-          <a:xfrm flipH="1" flipV="1">
-            <a:off x="7949047" y="2628762"/>
-            <a:ext cx="1844490" cy="1995091"/>
+          <a:xfrm flipV="1">
+            <a:off x="7944335" y="2628762"/>
+            <a:ext cx="4712" cy="382439"/>
           </a:xfrm>
           <a:prstGeom prst="straightConnector1">
             <a:avLst/>
@@ -4490,7 +4491,7 @@
         </p:nvSpPr>
         <p:spPr>
           <a:xfrm>
-            <a:off x="4566576" y="3740848"/>
+            <a:off x="3945291" y="1686592"/>
             <a:ext cx="1198364" cy="678063"/>
           </a:xfrm>
           <a:prstGeom prst="flowChartDecision">
@@ -4616,7 +4617,7 @@
         </p:nvSpPr>
         <p:spPr>
           <a:xfrm>
-            <a:off x="4682941" y="4988712"/>
+            <a:off x="3952658" y="5132254"/>
             <a:ext cx="1198364" cy="678063"/>
           </a:xfrm>
           <a:prstGeom prst="flowChartDecision">
@@ -4687,7 +4688,7 @@
         </p:nvSpPr>
         <p:spPr>
           <a:xfrm>
-            <a:off x="4665169" y="2018487"/>
+            <a:off x="6335707" y="4434806"/>
             <a:ext cx="1198364" cy="678063"/>
           </a:xfrm>
           <a:prstGeom prst="flowChartDecision">
@@ -4914,7 +4915,7 @@
         </p:nvSpPr>
         <p:spPr>
           <a:xfrm>
-            <a:off x="6320372" y="4193008"/>
+            <a:off x="4737995" y="4175519"/>
             <a:ext cx="882106" cy="557777"/>
           </a:xfrm>
           <a:prstGeom prst="flowChartProcess">
@@ -4994,9 +4995,9 @@
           <p:nvPr/>
         </p:nvCxnSpPr>
         <p:spPr>
-          <a:xfrm flipH="1">
-            <a:off x="6761425" y="3530960"/>
-            <a:ext cx="458436" cy="662048"/>
+          <a:xfrm>
+            <a:off x="5164561" y="3731639"/>
+            <a:ext cx="14487" cy="443880"/>
           </a:xfrm>
           <a:prstGeom prst="straightConnector1">
             <a:avLst/>
@@ -5032,14 +5033,14 @@
           <p:cNvCxnSpPr>
             <a:cxnSpLocks/>
             <a:stCxn id="25" idx="3"/>
-            <a:endCxn id="9" idx="2"/>
+            <a:endCxn id="9" idx="1"/>
           </p:cNvCxnSpPr>
           <p:nvPr/>
         </p:nvCxnSpPr>
         <p:spPr>
           <a:xfrm flipV="1">
-            <a:off x="7202478" y="4352544"/>
-            <a:ext cx="872385" cy="119353"/>
+            <a:off x="5620101" y="2126982"/>
+            <a:ext cx="142931" cy="2327426"/>
           </a:xfrm>
           <a:prstGeom prst="straightConnector1">
             <a:avLst/>
@@ -5137,9 +5138,9 @@
           <p:nvPr/>
         </p:nvCxnSpPr>
         <p:spPr>
-          <a:xfrm>
-            <a:off x="5881305" y="5327744"/>
-            <a:ext cx="351643" cy="45710"/>
+          <a:xfrm flipV="1">
+            <a:off x="5151022" y="5373454"/>
+            <a:ext cx="1081926" cy="97832"/>
           </a:xfrm>
           <a:prstGeom prst="straightConnector1">
             <a:avLst/>
@@ -5220,7 +5221,7 @@
         </p:nvSpPr>
         <p:spPr>
           <a:xfrm>
-            <a:off x="6021497" y="3191928"/>
+            <a:off x="3966197" y="3392607"/>
             <a:ext cx="1198364" cy="678063"/>
           </a:xfrm>
           <a:prstGeom prst="flowChartDecision">
@@ -5249,8 +5250,8 @@
           <a:p>
             <a:pPr algn="ctr"/>
             <a:r>
-              <a:rPr lang="en-US" sz="600" dirty="0" err="1"/>
-              <a:t>GAMM_compare_corstructs_analyses.Rmd</a:t>
+              <a:rPr lang="en-US" sz="600" dirty="0"/>
+              <a:t>12-GAMM_compare_corstructs_analyses.Rmd</a:t>
             </a:r>
             <a:endParaRPr lang="en-ZA" sz="600" dirty="0"/>
           </a:p>
@@ -5567,47 +5568,6 @@
           <a:xfrm>
             <a:off x="3263202" y="3947972"/>
             <a:ext cx="508144" cy="27287"/>
-          </a:xfrm>
-          <a:prstGeom prst="straightConnector1">
-            <a:avLst/>
-          </a:prstGeom>
-          <a:ln>
-            <a:tailEnd type="triangle"/>
-          </a:ln>
-        </p:spPr>
-        <p:style>
-          <a:lnRef idx="2">
-            <a:schemeClr val="accent1"/>
-          </a:lnRef>
-          <a:fillRef idx="0">
-            <a:schemeClr val="accent1"/>
-          </a:fillRef>
-          <a:effectRef idx="1">
-            <a:schemeClr val="accent1"/>
-          </a:effectRef>
-          <a:fontRef idx="minor">
-            <a:schemeClr val="tx1"/>
-          </a:fontRef>
-        </p:style>
-      </p:cxnSp>
-      <p:cxnSp>
-        <p:nvCxnSpPr>
-          <p:cNvPr id="184" name="Straight Arrow Connector 183">
-            <a:extLst>
-              <a:ext uri="{FF2B5EF4-FFF2-40B4-BE49-F238E27FC236}">
-                <a16:creationId xmlns:a16="http://schemas.microsoft.com/office/drawing/2014/main" id="{B3EF33C2-D423-65D2-0BFC-96FCF7E238C5}"/>
-              </a:ext>
-            </a:extLst>
-          </p:cNvPr>
-          <p:cNvCxnSpPr>
-            <a:cxnSpLocks/>
-          </p:cNvCxnSpPr>
-          <p:nvPr/>
-        </p:nvCxnSpPr>
-        <p:spPr>
-          <a:xfrm>
-            <a:off x="4451702" y="3634824"/>
-            <a:ext cx="0" cy="340435"/>
           </a:xfrm>
           <a:prstGeom prst="straightConnector1">
             <a:avLst/>
@@ -5651,49 +5611,6 @@
           <a:xfrm flipH="1" flipV="1">
             <a:off x="10135468" y="4288647"/>
             <a:ext cx="659239" cy="415482"/>
-          </a:xfrm>
-          <a:prstGeom prst="straightConnector1">
-            <a:avLst/>
-          </a:prstGeom>
-          <a:ln>
-            <a:tailEnd type="triangle"/>
-          </a:ln>
-        </p:spPr>
-        <p:style>
-          <a:lnRef idx="2">
-            <a:schemeClr val="accent1"/>
-          </a:lnRef>
-          <a:fillRef idx="0">
-            <a:schemeClr val="accent1"/>
-          </a:fillRef>
-          <a:effectRef idx="1">
-            <a:schemeClr val="accent1"/>
-          </a:effectRef>
-          <a:fontRef idx="minor">
-            <a:schemeClr val="tx1"/>
-          </a:fontRef>
-        </p:style>
-      </p:cxnSp>
-      <p:cxnSp>
-        <p:nvCxnSpPr>
-          <p:cNvPr id="186" name="Straight Arrow Connector 185">
-            <a:extLst>
-              <a:ext uri="{FF2B5EF4-FFF2-40B4-BE49-F238E27FC236}">
-                <a16:creationId xmlns:a16="http://schemas.microsoft.com/office/drawing/2014/main" id="{905CED2F-E13B-CF3B-CA93-38BF1C720440}"/>
-              </a:ext>
-            </a:extLst>
-          </p:cNvPr>
-          <p:cNvCxnSpPr>
-            <a:cxnSpLocks/>
-            <a:stCxn id="2" idx="3"/>
-            <a:endCxn id="75" idx="1"/>
-          </p:cNvCxnSpPr>
-          <p:nvPr/>
-        </p:nvCxnSpPr>
-        <p:spPr>
-          <a:xfrm flipV="1">
-            <a:off x="5764940" y="3530960"/>
-            <a:ext cx="256557" cy="548920"/>
           </a:xfrm>
           <a:prstGeom prst="straightConnector1">
             <a:avLst/>
@@ -6855,7 +6772,7 @@
         </p:nvGrpSpPr>
         <p:grpSpPr>
           <a:xfrm>
-            <a:off x="4074552" y="2861385"/>
+            <a:off x="3953485" y="2477859"/>
             <a:ext cx="1717444" cy="730009"/>
             <a:chOff x="4079329" y="2889182"/>
             <a:chExt cx="1717444" cy="730009"/>
@@ -6975,7 +6892,7 @@
         </p:nvSpPr>
         <p:spPr>
           <a:xfrm>
-            <a:off x="7992799" y="3174595"/>
+            <a:off x="5825751" y="2992949"/>
             <a:ext cx="1198364" cy="678063"/>
           </a:xfrm>
           <a:prstGeom prst="flowChartDecision">
@@ -7040,49 +6957,6 @@
           </a:p>
         </p:txBody>
       </p:sp>
-      <p:cxnSp>
-        <p:nvCxnSpPr>
-          <p:cNvPr id="58" name="Straight Arrow Connector 57">
-            <a:extLst>
-              <a:ext uri="{FF2B5EF4-FFF2-40B4-BE49-F238E27FC236}">
-                <a16:creationId xmlns:a16="http://schemas.microsoft.com/office/drawing/2014/main" id="{5820EA64-DEE3-6211-55AD-2C97054133AB}"/>
-              </a:ext>
-            </a:extLst>
-          </p:cNvPr>
-          <p:cNvCxnSpPr>
-            <a:cxnSpLocks/>
-            <a:stCxn id="25" idx="3"/>
-            <a:endCxn id="51" idx="1"/>
-          </p:cNvCxnSpPr>
-          <p:nvPr/>
-        </p:nvCxnSpPr>
-        <p:spPr>
-          <a:xfrm flipV="1">
-            <a:off x="7202478" y="3513627"/>
-            <a:ext cx="790321" cy="958270"/>
-          </a:xfrm>
-          <a:prstGeom prst="straightConnector1">
-            <a:avLst/>
-          </a:prstGeom>
-          <a:ln>
-            <a:tailEnd type="triangle"/>
-          </a:ln>
-        </p:spPr>
-        <p:style>
-          <a:lnRef idx="2">
-            <a:schemeClr val="accent1"/>
-          </a:lnRef>
-          <a:fillRef idx="0">
-            <a:schemeClr val="accent1"/>
-          </a:fillRef>
-          <a:effectRef idx="1">
-            <a:schemeClr val="accent1"/>
-          </a:effectRef>
-          <a:fontRef idx="minor">
-            <a:schemeClr val="tx1"/>
-          </a:fontRef>
-        </p:style>
-      </p:cxnSp>
       <p:sp>
         <p:nvSpPr>
           <p:cNvPr id="67" name="Flowchart: Process 66">
@@ -7097,7 +6971,7 @@
         </p:nvSpPr>
         <p:spPr>
           <a:xfrm>
-            <a:off x="9277972" y="3600802"/>
+            <a:off x="6587774" y="3878214"/>
             <a:ext cx="882106" cy="374457"/>
           </a:xfrm>
           <a:prstGeom prst="flowChartProcess">
@@ -7163,8 +7037,8 @@
         </p:nvCxnSpPr>
         <p:spPr>
           <a:xfrm>
-            <a:off x="9191163" y="3513627"/>
-            <a:ext cx="527862" cy="87175"/>
+            <a:off x="7024115" y="3331981"/>
+            <a:ext cx="4712" cy="546233"/>
           </a:xfrm>
           <a:prstGeom prst="straightConnector1">
             <a:avLst/>
@@ -7205,9 +7079,9 @@
           <p:nvPr/>
         </p:nvCxnSpPr>
         <p:spPr>
-          <a:xfrm flipH="1">
-            <a:off x="9182936" y="3975259"/>
-            <a:ext cx="536089" cy="319713"/>
+          <a:xfrm flipV="1">
+            <a:off x="7028827" y="3011201"/>
+            <a:ext cx="915508" cy="1241470"/>
           </a:xfrm>
           <a:prstGeom prst="straightConnector1">
             <a:avLst/>
@@ -7245,7 +7119,7 @@
         </p:nvSpPr>
         <p:spPr>
           <a:xfrm>
-            <a:off x="8583754" y="4294972"/>
+            <a:off x="7345153" y="3011201"/>
             <a:ext cx="1198364" cy="678063"/>
           </a:xfrm>
           <a:prstGeom prst="flowChartDecision">
@@ -7308,7 +7182,7 @@
         </p:nvSpPr>
         <p:spPr>
           <a:xfrm>
-            <a:off x="7475681" y="3674481"/>
+            <a:off x="5763032" y="1787950"/>
             <a:ext cx="1198364" cy="678063"/>
           </a:xfrm>
           <a:prstGeom prst="flowChartDecision">
@@ -7743,6 +7617,150 @@
           </a:fontRef>
         </p:style>
       </p:cxnSp>
+      <p:sp>
+        <p:nvSpPr>
+          <p:cNvPr id="248" name="TextBox 247">
+            <a:extLst>
+              <a:ext uri="{FF2B5EF4-FFF2-40B4-BE49-F238E27FC236}">
+                <a16:creationId xmlns:a16="http://schemas.microsoft.com/office/drawing/2014/main" id="{54B2AB5C-25C9-C4D1-BA88-76F9E28868BA}"/>
+              </a:ext>
+            </a:extLst>
+          </p:cNvPr>
+          <p:cNvSpPr txBox="1"/>
+          <p:nvPr/>
+        </p:nvSpPr>
+        <p:spPr>
+          <a:xfrm>
+            <a:off x="4046583" y="2374045"/>
+            <a:ext cx="1082834" cy="169277"/>
+          </a:xfrm>
+          <a:prstGeom prst="rect">
+            <a:avLst/>
+          </a:prstGeom>
+          <a:noFill/>
+        </p:spPr>
+        <p:txBody>
+          <a:bodyPr wrap="square" rtlCol="0">
+            <a:spAutoFit/>
+          </a:bodyPr>
+          <a:lstStyle/>
+          <a:p>
+            <a:r>
+              <a:rPr lang="en-US" sz="500" dirty="0"/>
+              <a:t>Choose distribution family</a:t>
+            </a:r>
+            <a:endParaRPr lang="en-ZA" sz="500" dirty="0"/>
+          </a:p>
+        </p:txBody>
+      </p:sp>
+      <p:sp>
+        <p:nvSpPr>
+          <p:cNvPr id="249" name="TextBox 248">
+            <a:extLst>
+              <a:ext uri="{FF2B5EF4-FFF2-40B4-BE49-F238E27FC236}">
+                <a16:creationId xmlns:a16="http://schemas.microsoft.com/office/drawing/2014/main" id="{B7CB845C-ABD1-B59F-0E79-43E23E003D1C}"/>
+              </a:ext>
+            </a:extLst>
+          </p:cNvPr>
+          <p:cNvSpPr txBox="1"/>
+          <p:nvPr/>
+        </p:nvSpPr>
+        <p:spPr>
+          <a:xfrm>
+            <a:off x="4256374" y="3201778"/>
+            <a:ext cx="595395" cy="169277"/>
+          </a:xfrm>
+          <a:prstGeom prst="rect">
+            <a:avLst/>
+          </a:prstGeom>
+          <a:noFill/>
+        </p:spPr>
+        <p:txBody>
+          <a:bodyPr wrap="square" rtlCol="0">
+            <a:spAutoFit/>
+          </a:bodyPr>
+          <a:lstStyle/>
+          <a:p>
+            <a:r>
+              <a:rPr lang="en-US" sz="500" dirty="0"/>
+              <a:t>Choose Spline</a:t>
+            </a:r>
+            <a:endParaRPr lang="en-ZA" sz="500" dirty="0"/>
+          </a:p>
+        </p:txBody>
+      </p:sp>
+      <p:sp>
+        <p:nvSpPr>
+          <p:cNvPr id="251" name="TextBox 250">
+            <a:extLst>
+              <a:ext uri="{FF2B5EF4-FFF2-40B4-BE49-F238E27FC236}">
+                <a16:creationId xmlns:a16="http://schemas.microsoft.com/office/drawing/2014/main" id="{DA10A53F-F58D-A0FF-33A3-7C4C9EC30C94}"/>
+              </a:ext>
+            </a:extLst>
+          </p:cNvPr>
+          <p:cNvSpPr txBox="1"/>
+          <p:nvPr/>
+        </p:nvSpPr>
+        <p:spPr>
+          <a:xfrm>
+            <a:off x="6155242" y="2558824"/>
+            <a:ext cx="960451" cy="246221"/>
+          </a:xfrm>
+          <a:prstGeom prst="rect">
+            <a:avLst/>
+          </a:prstGeom>
+          <a:noFill/>
+        </p:spPr>
+        <p:txBody>
+          <a:bodyPr wrap="square" rtlCol="0">
+            <a:spAutoFit/>
+          </a:bodyPr>
+          <a:lstStyle/>
+          <a:p>
+            <a:r>
+              <a:rPr lang="en-US" sz="500" dirty="0"/>
+              <a:t>Choose correlation structure </a:t>
+            </a:r>
+            <a:endParaRPr lang="en-ZA" sz="500" dirty="0"/>
+          </a:p>
+        </p:txBody>
+      </p:sp>
+      <p:sp>
+        <p:nvSpPr>
+          <p:cNvPr id="50" name="TextBox 49">
+            <a:extLst>
+              <a:ext uri="{FF2B5EF4-FFF2-40B4-BE49-F238E27FC236}">
+                <a16:creationId xmlns:a16="http://schemas.microsoft.com/office/drawing/2014/main" id="{72E1159E-0C06-DDFA-9BED-C4206E1AF9B2}"/>
+              </a:ext>
+            </a:extLst>
+          </p:cNvPr>
+          <p:cNvSpPr txBox="1"/>
+          <p:nvPr/>
+        </p:nvSpPr>
+        <p:spPr>
+          <a:xfrm>
+            <a:off x="7362221" y="3690415"/>
+            <a:ext cx="595395" cy="169277"/>
+          </a:xfrm>
+          <a:prstGeom prst="rect">
+            <a:avLst/>
+          </a:prstGeom>
+          <a:noFill/>
+        </p:spPr>
+        <p:txBody>
+          <a:bodyPr wrap="square" rtlCol="0">
+            <a:spAutoFit/>
+          </a:bodyPr>
+          <a:lstStyle/>
+          <a:p>
+            <a:r>
+              <a:rPr lang="en-US" sz="500"/>
+              <a:t>Choose Model</a:t>
+            </a:r>
+            <a:endParaRPr lang="en-ZA" sz="500" dirty="0"/>
+          </a:p>
+        </p:txBody>
+      </p:sp>
     </p:spTree>
     <p:extLst>
       <p:ext uri="{BB962C8B-B14F-4D97-AF65-F5344CB8AC3E}">

</xml_diff>

<commit_message>
Updated Script 13 processing msgdm analyses to choose correlation structure
</commit_message>
<xml_diff>
--- a/script_relationships.pptx
+++ b/script_relationships.pptx
@@ -261,7 +261,7 @@
           <a:p>
             <a:fld id="{0E339DDD-9EE9-44F5-8997-0932F1FFC27B}" type="datetimeFigureOut">
               <a:rPr lang="en-ZA" smtClean="0"/>
-              <a:t>2026/06/04</a:t>
+              <a:t>2026/07/13</a:t>
             </a:fld>
             <a:endParaRPr lang="en-ZA"/>
           </a:p>
@@ -461,7 +461,7 @@
           <a:p>
             <a:fld id="{0E339DDD-9EE9-44F5-8997-0932F1FFC27B}" type="datetimeFigureOut">
               <a:rPr lang="en-ZA" smtClean="0"/>
-              <a:t>2026/06/04</a:t>
+              <a:t>2026/07/13</a:t>
             </a:fld>
             <a:endParaRPr lang="en-ZA"/>
           </a:p>
@@ -671,7 +671,7 @@
           <a:p>
             <a:fld id="{0E339DDD-9EE9-44F5-8997-0932F1FFC27B}" type="datetimeFigureOut">
               <a:rPr lang="en-ZA" smtClean="0"/>
-              <a:t>2026/06/04</a:t>
+              <a:t>2026/07/13</a:t>
             </a:fld>
             <a:endParaRPr lang="en-ZA"/>
           </a:p>
@@ -871,7 +871,7 @@
           <a:p>
             <a:fld id="{0E339DDD-9EE9-44F5-8997-0932F1FFC27B}" type="datetimeFigureOut">
               <a:rPr lang="en-ZA" smtClean="0"/>
-              <a:t>2026/06/04</a:t>
+              <a:t>2026/07/13</a:t>
             </a:fld>
             <a:endParaRPr lang="en-ZA"/>
           </a:p>
@@ -1147,7 +1147,7 @@
           <a:p>
             <a:fld id="{0E339DDD-9EE9-44F5-8997-0932F1FFC27B}" type="datetimeFigureOut">
               <a:rPr lang="en-ZA" smtClean="0"/>
-              <a:t>2026/06/04</a:t>
+              <a:t>2026/07/13</a:t>
             </a:fld>
             <a:endParaRPr lang="en-ZA"/>
           </a:p>
@@ -1415,7 +1415,7 @@
           <a:p>
             <a:fld id="{0E339DDD-9EE9-44F5-8997-0932F1FFC27B}" type="datetimeFigureOut">
               <a:rPr lang="en-ZA" smtClean="0"/>
-              <a:t>2026/06/04</a:t>
+              <a:t>2026/07/13</a:t>
             </a:fld>
             <a:endParaRPr lang="en-ZA"/>
           </a:p>
@@ -1830,7 +1830,7 @@
           <a:p>
             <a:fld id="{0E339DDD-9EE9-44F5-8997-0932F1FFC27B}" type="datetimeFigureOut">
               <a:rPr lang="en-ZA" smtClean="0"/>
-              <a:t>2026/06/04</a:t>
+              <a:t>2026/07/13</a:t>
             </a:fld>
             <a:endParaRPr lang="en-ZA"/>
           </a:p>
@@ -1972,7 +1972,7 @@
           <a:p>
             <a:fld id="{0E339DDD-9EE9-44F5-8997-0932F1FFC27B}" type="datetimeFigureOut">
               <a:rPr lang="en-ZA" smtClean="0"/>
-              <a:t>2026/06/04</a:t>
+              <a:t>2026/07/13</a:t>
             </a:fld>
             <a:endParaRPr lang="en-ZA"/>
           </a:p>
@@ -2085,7 +2085,7 @@
           <a:p>
             <a:fld id="{0E339DDD-9EE9-44F5-8997-0932F1FFC27B}" type="datetimeFigureOut">
               <a:rPr lang="en-ZA" smtClean="0"/>
-              <a:t>2026/06/04</a:t>
+              <a:t>2026/07/13</a:t>
             </a:fld>
             <a:endParaRPr lang="en-ZA"/>
           </a:p>
@@ -2398,7 +2398,7 @@
           <a:p>
             <a:fld id="{0E339DDD-9EE9-44F5-8997-0932F1FFC27B}" type="datetimeFigureOut">
               <a:rPr lang="en-ZA" smtClean="0"/>
-              <a:t>2026/06/04</a:t>
+              <a:t>2026/07/13</a:t>
             </a:fld>
             <a:endParaRPr lang="en-ZA"/>
           </a:p>
@@ -2687,7 +2687,7 @@
           <a:p>
             <a:fld id="{0E339DDD-9EE9-44F5-8997-0932F1FFC27B}" type="datetimeFigureOut">
               <a:rPr lang="en-ZA" smtClean="0"/>
-              <a:t>2026/06/04</a:t>
+              <a:t>2026/07/13</a:t>
             </a:fld>
             <a:endParaRPr lang="en-ZA"/>
           </a:p>
@@ -2930,7 +2930,7 @@
           <a:p>
             <a:fld id="{0E339DDD-9EE9-44F5-8997-0932F1FFC27B}" type="datetimeFigureOut">
               <a:rPr lang="en-ZA" smtClean="0"/>
-              <a:t>2026/06/04</a:t>
+              <a:t>2026/07/13</a:t>
             </a:fld>
             <a:endParaRPr lang="en-ZA"/>
           </a:p>
@@ -5251,7 +5251,7 @@
             <a:pPr algn="ctr"/>
             <a:r>
               <a:rPr lang="en-US" sz="600" dirty="0"/>
-              <a:t>12-GAMM_compare_corstructs_analyses.Rmd</a:t>
+              <a:t>12_GAMM_compare_corstructs_analyses.Rmd</a:t>
             </a:r>
             <a:endParaRPr lang="en-ZA" sz="600" dirty="0"/>
           </a:p>
@@ -7216,12 +7216,12 @@
           <a:p>
             <a:pPr algn="ctr"/>
             <a:r>
-              <a:rPr lang="en-US" sz="600" dirty="0" err="1">
+              <a:rPr lang="en-US" sz="600" dirty="0">
                 <a:solidFill>
                   <a:srgbClr val="7030A0"/>
                 </a:solidFill>
               </a:rPr>
-              <a:t>Process_GAMM_analyses.Rmd</a:t>
+              <a:t>13_Process_GAMM_analyses.Rmd</a:t>
             </a:r>
             <a:endParaRPr lang="en-ZA" sz="600" dirty="0">
               <a:solidFill>
@@ -7703,7 +7703,7 @@
         </p:nvSpPr>
         <p:spPr>
           <a:xfrm>
-            <a:off x="6155242" y="2558824"/>
+            <a:off x="6039264" y="2569757"/>
             <a:ext cx="960451" cy="246221"/>
           </a:xfrm>
           <a:prstGeom prst="rect">

</xml_diff>

<commit_message>
Moved making of gamm input to script 2_Butterflies_combine_env_data annotated and updated mardown for 14_GAMM_model_selection and 15_process_GAMMS_single_result_output
</commit_message>
<xml_diff>
--- a/script_relationships.pptx
+++ b/script_relationships.pptx
@@ -261,7 +261,7 @@
           <a:p>
             <a:fld id="{0E339DDD-9EE9-44F5-8997-0932F1FFC27B}" type="datetimeFigureOut">
               <a:rPr lang="en-ZA" smtClean="0"/>
-              <a:t>2026/07/13</a:t>
+              <a:t>2026/07/20</a:t>
             </a:fld>
             <a:endParaRPr lang="en-ZA"/>
           </a:p>
@@ -461,7 +461,7 @@
           <a:p>
             <a:fld id="{0E339DDD-9EE9-44F5-8997-0932F1FFC27B}" type="datetimeFigureOut">
               <a:rPr lang="en-ZA" smtClean="0"/>
-              <a:t>2026/07/13</a:t>
+              <a:t>2026/07/20</a:t>
             </a:fld>
             <a:endParaRPr lang="en-ZA"/>
           </a:p>
@@ -671,7 +671,7 @@
           <a:p>
             <a:fld id="{0E339DDD-9EE9-44F5-8997-0932F1FFC27B}" type="datetimeFigureOut">
               <a:rPr lang="en-ZA" smtClean="0"/>
-              <a:t>2026/07/13</a:t>
+              <a:t>2026/07/20</a:t>
             </a:fld>
             <a:endParaRPr lang="en-ZA"/>
           </a:p>
@@ -871,7 +871,7 @@
           <a:p>
             <a:fld id="{0E339DDD-9EE9-44F5-8997-0932F1FFC27B}" type="datetimeFigureOut">
               <a:rPr lang="en-ZA" smtClean="0"/>
-              <a:t>2026/07/13</a:t>
+              <a:t>2026/07/20</a:t>
             </a:fld>
             <a:endParaRPr lang="en-ZA"/>
           </a:p>
@@ -1147,7 +1147,7 @@
           <a:p>
             <a:fld id="{0E339DDD-9EE9-44F5-8997-0932F1FFC27B}" type="datetimeFigureOut">
               <a:rPr lang="en-ZA" smtClean="0"/>
-              <a:t>2026/07/13</a:t>
+              <a:t>2026/07/20</a:t>
             </a:fld>
             <a:endParaRPr lang="en-ZA"/>
           </a:p>
@@ -1415,7 +1415,7 @@
           <a:p>
             <a:fld id="{0E339DDD-9EE9-44F5-8997-0932F1FFC27B}" type="datetimeFigureOut">
               <a:rPr lang="en-ZA" smtClean="0"/>
-              <a:t>2026/07/13</a:t>
+              <a:t>2026/07/20</a:t>
             </a:fld>
             <a:endParaRPr lang="en-ZA"/>
           </a:p>
@@ -1830,7 +1830,7 @@
           <a:p>
             <a:fld id="{0E339DDD-9EE9-44F5-8997-0932F1FFC27B}" type="datetimeFigureOut">
               <a:rPr lang="en-ZA" smtClean="0"/>
-              <a:t>2026/07/13</a:t>
+              <a:t>2026/07/20</a:t>
             </a:fld>
             <a:endParaRPr lang="en-ZA"/>
           </a:p>
@@ -1972,7 +1972,7 @@
           <a:p>
             <a:fld id="{0E339DDD-9EE9-44F5-8997-0932F1FFC27B}" type="datetimeFigureOut">
               <a:rPr lang="en-ZA" smtClean="0"/>
-              <a:t>2026/07/13</a:t>
+              <a:t>2026/07/20</a:t>
             </a:fld>
             <a:endParaRPr lang="en-ZA"/>
           </a:p>
@@ -2085,7 +2085,7 @@
           <a:p>
             <a:fld id="{0E339DDD-9EE9-44F5-8997-0932F1FFC27B}" type="datetimeFigureOut">
               <a:rPr lang="en-ZA" smtClean="0"/>
-              <a:t>2026/07/13</a:t>
+              <a:t>2026/07/20</a:t>
             </a:fld>
             <a:endParaRPr lang="en-ZA"/>
           </a:p>
@@ -2398,7 +2398,7 @@
           <a:p>
             <a:fld id="{0E339DDD-9EE9-44F5-8997-0932F1FFC27B}" type="datetimeFigureOut">
               <a:rPr lang="en-ZA" smtClean="0"/>
-              <a:t>2026/07/13</a:t>
+              <a:t>2026/07/20</a:t>
             </a:fld>
             <a:endParaRPr lang="en-ZA"/>
           </a:p>
@@ -2687,7 +2687,7 @@
           <a:p>
             <a:fld id="{0E339DDD-9EE9-44F5-8997-0932F1FFC27B}" type="datetimeFigureOut">
               <a:rPr lang="en-ZA" smtClean="0"/>
-              <a:t>2026/07/13</a:t>
+              <a:t>2026/07/20</a:t>
             </a:fld>
             <a:endParaRPr lang="en-ZA"/>
           </a:p>
@@ -2930,7 +2930,7 @@
           <a:p>
             <a:fld id="{0E339DDD-9EE9-44F5-8997-0932F1FFC27B}" type="datetimeFigureOut">
               <a:rPr lang="en-ZA" smtClean="0"/>
-              <a:t>2026/07/13</a:t>
+              <a:t>2026/07/20</a:t>
             </a:fld>
             <a:endParaRPr lang="en-ZA"/>
           </a:p>
@@ -4951,18 +4951,6 @@
           <a:p>
             <a:pPr algn="ctr"/>
             <a:r>
-              <a:rPr lang="en-ZA" sz="600" dirty="0"/>
-              <a:t>…_</a:t>
-            </a:r>
-            <a:r>
-              <a:rPr lang="en-ZA" sz="600" dirty="0" err="1"/>
-              <a:t>gamm_input.Rds</a:t>
-            </a:r>
-            <a:endParaRPr lang="en-ZA" sz="600" dirty="0"/>
-          </a:p>
-          <a:p>
-            <a:pPr algn="ctr"/>
-            <a:r>
               <a:rPr lang="en-US" sz="600" dirty="0"/>
               <a:t>…</a:t>
             </a:r>
@@ -6926,18 +6914,13 @@
           <a:p>
             <a:pPr algn="ctr"/>
             <a:r>
-              <a:rPr lang="en-US" sz="600" dirty="0" err="1">
+              <a:rPr lang="en-US" sz="600" dirty="0">
                 <a:solidFill>
                   <a:srgbClr val="7030A0"/>
                 </a:solidFill>
               </a:rPr>
-              <a:t>GAMM_model_selection.Rmd</a:t>
-            </a:r>
-            <a:endParaRPr lang="en-US" sz="600" dirty="0">
-              <a:solidFill>
-                <a:srgbClr val="7030A0"/>
-              </a:solidFill>
-            </a:endParaRPr>
+              <a:t>14_GAMM_model_selection.Rmd</a:t>
+            </a:r>
           </a:p>
           <a:p>
             <a:pPr algn="ctr"/>
@@ -7153,12 +7136,20 @@
           <a:p>
             <a:pPr algn="ctr"/>
             <a:r>
+              <a:rPr lang="en-US" sz="600">
+                <a:solidFill>
+                  <a:srgbClr val="7030A0"/>
+                </a:solidFill>
+              </a:rPr>
+              <a:t>15_process</a:t>
+            </a:r>
+            <a:r>
               <a:rPr lang="en-US" sz="600" dirty="0" err="1">
                 <a:solidFill>
                   <a:srgbClr val="7030A0"/>
                 </a:solidFill>
               </a:rPr>
-              <a:t>process_GAMMS_single_result_output.Rmd</a:t>
+              <a:t>_GAMMS_single_result_output.Rmd</a:t>
             </a:r>
             <a:endParaRPr lang="en-ZA" sz="600" dirty="0">
               <a:solidFill>

</xml_diff>

<commit_message>
Renamed 5_run_zeta_msgdm.Rmd to 5_Call_msgdm_and_gamm_scripts.Rmd
Updated readme on order to call scripts,

updated function code and order of chunks to be in same order as script names
</commit_message>
<xml_diff>
--- a/script_relationships.pptx
+++ b/script_relationships.pptx
@@ -6,6 +6,7 @@
   </p:sldMasterIdLst>
   <p:sldIdLst>
     <p:sldId id="256" r:id="rId2"/>
+    <p:sldId id="257" r:id="rId3"/>
   </p:sldIdLst>
   <p:sldSz cx="12192000" cy="6858000"/>
   <p:notesSz cx="6858000" cy="9144000"/>
@@ -261,7 +262,7 @@
           <a:p>
             <a:fld id="{0E339DDD-9EE9-44F5-8997-0932F1FFC27B}" type="datetimeFigureOut">
               <a:rPr lang="en-ZA" smtClean="0"/>
-              <a:t>2026/07/20</a:t>
+              <a:t>2026/07/21</a:t>
             </a:fld>
             <a:endParaRPr lang="en-ZA"/>
           </a:p>
@@ -461,7 +462,7 @@
           <a:p>
             <a:fld id="{0E339DDD-9EE9-44F5-8997-0932F1FFC27B}" type="datetimeFigureOut">
               <a:rPr lang="en-ZA" smtClean="0"/>
-              <a:t>2026/07/20</a:t>
+              <a:t>2026/07/21</a:t>
             </a:fld>
             <a:endParaRPr lang="en-ZA"/>
           </a:p>
@@ -671,7 +672,7 @@
           <a:p>
             <a:fld id="{0E339DDD-9EE9-44F5-8997-0932F1FFC27B}" type="datetimeFigureOut">
               <a:rPr lang="en-ZA" smtClean="0"/>
-              <a:t>2026/07/20</a:t>
+              <a:t>2026/07/21</a:t>
             </a:fld>
             <a:endParaRPr lang="en-ZA"/>
           </a:p>
@@ -871,7 +872,7 @@
           <a:p>
             <a:fld id="{0E339DDD-9EE9-44F5-8997-0932F1FFC27B}" type="datetimeFigureOut">
               <a:rPr lang="en-ZA" smtClean="0"/>
-              <a:t>2026/07/20</a:t>
+              <a:t>2026/07/21</a:t>
             </a:fld>
             <a:endParaRPr lang="en-ZA"/>
           </a:p>
@@ -1147,7 +1148,7 @@
           <a:p>
             <a:fld id="{0E339DDD-9EE9-44F5-8997-0932F1FFC27B}" type="datetimeFigureOut">
               <a:rPr lang="en-ZA" smtClean="0"/>
-              <a:t>2026/07/20</a:t>
+              <a:t>2026/07/21</a:t>
             </a:fld>
             <a:endParaRPr lang="en-ZA"/>
           </a:p>
@@ -1415,7 +1416,7 @@
           <a:p>
             <a:fld id="{0E339DDD-9EE9-44F5-8997-0932F1FFC27B}" type="datetimeFigureOut">
               <a:rPr lang="en-ZA" smtClean="0"/>
-              <a:t>2026/07/20</a:t>
+              <a:t>2026/07/21</a:t>
             </a:fld>
             <a:endParaRPr lang="en-ZA"/>
           </a:p>
@@ -1830,7 +1831,7 @@
           <a:p>
             <a:fld id="{0E339DDD-9EE9-44F5-8997-0932F1FFC27B}" type="datetimeFigureOut">
               <a:rPr lang="en-ZA" smtClean="0"/>
-              <a:t>2026/07/20</a:t>
+              <a:t>2026/07/21</a:t>
             </a:fld>
             <a:endParaRPr lang="en-ZA"/>
           </a:p>
@@ -1972,7 +1973,7 @@
           <a:p>
             <a:fld id="{0E339DDD-9EE9-44F5-8997-0932F1FFC27B}" type="datetimeFigureOut">
               <a:rPr lang="en-ZA" smtClean="0"/>
-              <a:t>2026/07/20</a:t>
+              <a:t>2026/07/21</a:t>
             </a:fld>
             <a:endParaRPr lang="en-ZA"/>
           </a:p>
@@ -2085,7 +2086,7 @@
           <a:p>
             <a:fld id="{0E339DDD-9EE9-44F5-8997-0932F1FFC27B}" type="datetimeFigureOut">
               <a:rPr lang="en-ZA" smtClean="0"/>
-              <a:t>2026/07/20</a:t>
+              <a:t>2026/07/21</a:t>
             </a:fld>
             <a:endParaRPr lang="en-ZA"/>
           </a:p>
@@ -2398,7 +2399,7 @@
           <a:p>
             <a:fld id="{0E339DDD-9EE9-44F5-8997-0932F1FFC27B}" type="datetimeFigureOut">
               <a:rPr lang="en-ZA" smtClean="0"/>
-              <a:t>2026/07/20</a:t>
+              <a:t>2026/07/21</a:t>
             </a:fld>
             <a:endParaRPr lang="en-ZA"/>
           </a:p>
@@ -2687,7 +2688,7 @@
           <a:p>
             <a:fld id="{0E339DDD-9EE9-44F5-8997-0932F1FFC27B}" type="datetimeFigureOut">
               <a:rPr lang="en-ZA" smtClean="0"/>
-              <a:t>2026/07/20</a:t>
+              <a:t>2026/07/21</a:t>
             </a:fld>
             <a:endParaRPr lang="en-ZA"/>
           </a:p>
@@ -2930,7 +2931,7 @@
           <a:p>
             <a:fld id="{0E339DDD-9EE9-44F5-8997-0932F1FFC27B}" type="datetimeFigureOut">
               <a:rPr lang="en-ZA" smtClean="0"/>
-              <a:t>2026/07/20</a:t>
+              <a:t>2026/07/21</a:t>
             </a:fld>
             <a:endParaRPr lang="en-ZA"/>
           </a:p>
@@ -6603,10 +6604,9 @@
           <a:p>
             <a:pPr algn="ctr"/>
             <a:r>
-              <a:rPr lang="en-ZA" sz="700" dirty="0" err="1"/>
-              <a:t>Gamm_multipanel_fig.Rmd</a:t>
-            </a:r>
-            <a:endParaRPr lang="en-ZA" sz="700" dirty="0"/>
+              <a:rPr lang="en-ZA" sz="700" dirty="0"/>
+              <a:t>16_GAMM_multipanel_plot.Rmd</a:t>
+            </a:r>
           </a:p>
         </p:txBody>
       </p:sp>
@@ -7756,6 +7756,98 @@
     <p:extLst>
       <p:ext uri="{BB962C8B-B14F-4D97-AF65-F5344CB8AC3E}">
         <p14:creationId xmlns:p14="http://schemas.microsoft.com/office/powerpoint/2010/main" val="852702447"/>
+      </p:ext>
+    </p:extLst>
+  </p:cSld>
+  <p:clrMapOvr>
+    <a:masterClrMapping/>
+  </p:clrMapOvr>
+</p:sld>
+</file>
+
+<file path=ppt/slides/slide2.xml><?xml version="1.0" encoding="utf-8"?>
+<p:sld xmlns:a="http://schemas.openxmlformats.org/drawingml/2006/main" xmlns:r="http://schemas.openxmlformats.org/officeDocument/2006/relationships" xmlns:p="http://schemas.openxmlformats.org/presentationml/2006/main">
+  <p:cSld>
+    <p:spTree>
+      <p:nvGrpSpPr>
+        <p:cNvPr id="1" name=""/>
+        <p:cNvGrpSpPr/>
+        <p:nvPr/>
+      </p:nvGrpSpPr>
+      <p:grpSpPr>
+        <a:xfrm>
+          <a:off x="0" y="0"/>
+          <a:ext cx="0" cy="0"/>
+          <a:chOff x="0" y="0"/>
+          <a:chExt cx="0" cy="0"/>
+        </a:xfrm>
+      </p:grpSpPr>
+      <p:sp>
+        <p:nvSpPr>
+          <p:cNvPr id="2" name="Title 1">
+            <a:extLst>
+              <a:ext uri="{FF2B5EF4-FFF2-40B4-BE49-F238E27FC236}">
+                <a16:creationId xmlns:a16="http://schemas.microsoft.com/office/drawing/2014/main" id="{C55F611E-2533-D96D-372A-D0DEDD28A7A3}"/>
+              </a:ext>
+            </a:extLst>
+          </p:cNvPr>
+          <p:cNvSpPr>
+            <a:spLocks noGrp="1"/>
+          </p:cNvSpPr>
+          <p:nvPr>
+            <p:ph type="title"/>
+          </p:nvPr>
+        </p:nvSpPr>
+        <p:spPr/>
+        <p:txBody>
+          <a:bodyPr/>
+          <a:lstStyle/>
+          <a:p>
+            <a:r>
+              <a:rPr lang="en-US" dirty="0"/>
+              <a:t>Separate above slide into several slide</a:t>
+            </a:r>
+            <a:endParaRPr lang="en-ZA" dirty="0"/>
+          </a:p>
+        </p:txBody>
+      </p:sp>
+      <p:sp>
+        <p:nvSpPr>
+          <p:cNvPr id="3" name="Content Placeholder 2">
+            <a:extLst>
+              <a:ext uri="{FF2B5EF4-FFF2-40B4-BE49-F238E27FC236}">
+                <a16:creationId xmlns:a16="http://schemas.microsoft.com/office/drawing/2014/main" id="{6B498BE4-7584-9730-94DF-07C05A21F8F2}"/>
+              </a:ext>
+            </a:extLst>
+          </p:cNvPr>
+          <p:cNvSpPr>
+            <a:spLocks noGrp="1"/>
+          </p:cNvSpPr>
+          <p:nvPr>
+            <p:ph idx="1"/>
+          </p:nvPr>
+        </p:nvSpPr>
+        <p:spPr/>
+        <p:txBody>
+          <a:bodyPr/>
+          <a:lstStyle/>
+          <a:p>
+            <a:r>
+              <a:rPr lang="en-US" dirty="0"/>
+              <a:t>Check consistency </a:t>
+            </a:r>
+            <a:r>
+              <a:rPr lang="en-US"/>
+              <a:t>with readme</a:t>
+            </a:r>
+            <a:endParaRPr lang="en-ZA"/>
+          </a:p>
+        </p:txBody>
+      </p:sp>
+    </p:spTree>
+    <p:extLst>
+      <p:ext uri="{BB962C8B-B14F-4D97-AF65-F5344CB8AC3E}">
+        <p14:creationId xmlns:p14="http://schemas.microsoft.com/office/powerpoint/2010/main" val="3508468127"/>
       </p:ext>
     </p:extLst>
   </p:cSld>

</xml_diff>